<commit_message>
Add installation and remediation evidence to presentation
Co-authored-by: Copilot <223556219+Copilot@users.noreply.github.com>
</commit_message>
<xml_diff>
--- a/docs/MevzuAI_Sunum_Guncel.pptx
+++ b/docs/MevzuAI_Sunum_Guncel.pptx
@@ -27,6 +27,10 @@
     <p:sldId id="275" r:id="rId26"/>
     <p:sldId id="276" r:id="rId27"/>
     <p:sldId id="277" r:id="rId28"/>
+    <p:sldId id="278" r:id="rId29"/>
+    <p:sldId id="279" r:id="rId30"/>
+    <p:sldId id="280" r:id="rId31"/>
+    <p:sldId id="281" r:id="rId32"/>
   </p:sldIdLst>
   <p:sldSz cx="12192119" cy="6858000" type="screen4x3"/>
   <p:notesSz cx="6858000" cy="9144000"/>
@@ -19530,6 +19534,782 @@
 </p:sld>
 </file>
 
+<file path=ppt/slides/slide23.xml><?xml version="1.0" encoding="utf-8"?>
+<p:sld xmlns:a="http://schemas.openxmlformats.org/drawingml/2006/main" xmlns:p="http://schemas.openxmlformats.org/presentationml/2006/main" xmlns:r="http://schemas.openxmlformats.org/officeDocument/2006/relationships">
+  <p:cSld>
+    <p:bg>
+      <p:bgPr>
+        <a:solidFill>
+          <a:srgbClr val="F7F9FC"/>
+        </a:solidFill>
+        <a:effectLst/>
+      </p:bgPr>
+    </p:bg>
+    <p:spTree>
+      <p:nvGrpSpPr>
+        <p:cNvPr id="1" name=""/>
+        <p:cNvGrpSpPr/>
+        <p:nvPr/>
+      </p:nvGrpSpPr>
+      <p:grpSpPr/>
+      <p:sp>
+        <p:nvSpPr>
+          <p:cNvPr id="2" name="TextBox 1"/>
+          <p:cNvSpPr txBox="1"/>
+          <p:nvPr/>
+        </p:nvSpPr>
+        <p:spPr>
+          <a:xfrm>
+            <a:off x="594360" y="274320"/>
+            <a:ext cx="10972800" cy="228600"/>
+          </a:xfrm>
+          <a:prstGeom prst="rect">
+            <a:avLst/>
+          </a:prstGeom>
+          <a:noFill/>
+        </p:spPr>
+        <p:txBody>
+          <a:bodyPr wrap="square" lIns="73152" rIns="73152" tIns="36576" bIns="27432" anchor="ctr">
+            <a:spAutoFit/>
+          </a:bodyPr>
+          <a:lstStyle/>
+          <a:p>
+            <a:pPr>
+              <a:defRPr sz="1000" b="1">
+                <a:solidFill>
+                  <a:srgbClr val="00AFA0"/>
+                </a:solidFill>
+                <a:latin typeface="Aptos"/>
+              </a:defRPr>
+            </a:pPr>
+            <a:r>
+              <a:t>KURULUM · AŞAMA GÖRSELİ</a:t>
+            </a:r>
+          </a:p>
+        </p:txBody>
+      </p:sp>
+      <p:sp>
+        <p:nvSpPr>
+          <p:cNvPr id="3" name="TextBox 2"/>
+          <p:cNvSpPr txBox="1"/>
+          <p:nvPr/>
+        </p:nvSpPr>
+        <p:spPr>
+          <a:xfrm>
+            <a:off x="594360" y="594360"/>
+            <a:ext cx="10972800" cy="502920"/>
+          </a:xfrm>
+          <a:prstGeom prst="rect">
+            <a:avLst/>
+          </a:prstGeom>
+          <a:noFill/>
+        </p:spPr>
+        <p:txBody>
+          <a:bodyPr wrap="square" lIns="73152" rIns="73152" tIns="36576" bIns="27432" anchor="ctr">
+            <a:spAutoFit/>
+          </a:bodyPr>
+          <a:lstStyle/>
+          <a:p>
+            <a:pPr>
+              <a:defRPr sz="2400" b="1">
+                <a:solidFill>
+                  <a:srgbClr val="112240"/>
+                </a:solidFill>
+                <a:latin typeface="Aptos"/>
+              </a:defRPr>
+            </a:pPr>
+            <a:r>
+              <a:t>Kurulum aşamaları ve açık onay kapıları</a:t>
+            </a:r>
+          </a:p>
+        </p:txBody>
+      </p:sp>
+      <p:sp>
+        <p:nvSpPr>
+          <p:cNvPr id="4" name="TextBox 3"/>
+          <p:cNvSpPr txBox="1"/>
+          <p:nvPr/>
+        </p:nvSpPr>
+        <p:spPr>
+          <a:xfrm>
+            <a:off x="621792" y="1115568"/>
+            <a:ext cx="10972800" cy="384048"/>
+          </a:xfrm>
+          <a:prstGeom prst="rect">
+            <a:avLst/>
+          </a:prstGeom>
+          <a:noFill/>
+        </p:spPr>
+        <p:txBody>
+          <a:bodyPr wrap="square" lIns="73152" rIns="73152" tIns="36576" bIns="27432" anchor="ctr">
+            <a:spAutoFit/>
+          </a:bodyPr>
+          <a:lstStyle/>
+          <a:p>
+            <a:pPr>
+              <a:defRPr sz="1100" b="0">
+                <a:solidFill>
+                  <a:srgbClr val="637389"/>
+                </a:solidFill>
+                <a:latin typeface="Aptos"/>
+              </a:defRPr>
+            </a:pPr>
+            <a:r>
+              <a:t>install.sh kaynak kodundan sıralandı; bu makinede yapılmış bir kurulum kaydı olarak sunulmaz.</a:t>
+            </a:r>
+          </a:p>
+        </p:txBody>
+      </p:sp>
+      <p:pic>
+        <p:nvPicPr>
+          <p:cNvPr id="5" name="Picture 4" descr="kurulum_asamalari.png"/>
+          <p:cNvPicPr>
+            <a:picLocks noChangeAspect="1"/>
+          </p:cNvPicPr>
+          <p:nvPr/>
+        </p:nvPicPr>
+        <p:blipFill>
+          <a:blip r:embed="rId2"/>
+          <a:stretch>
+            <a:fillRect/>
+          </a:stretch>
+        </p:blipFill>
+        <p:spPr>
+          <a:xfrm>
+            <a:off x="621792" y="1664208"/>
+            <a:ext cx="10972800" cy="4507992"/>
+          </a:xfrm>
+          <a:prstGeom prst="rect">
+            <a:avLst/>
+          </a:prstGeom>
+        </p:spPr>
+      </p:pic>
+      <p:sp>
+        <p:nvSpPr>
+          <p:cNvPr id="6" name="TextBox 5"/>
+          <p:cNvSpPr txBox="1"/>
+          <p:nvPr/>
+        </p:nvSpPr>
+        <p:spPr>
+          <a:xfrm>
+            <a:off x="685800" y="6263640"/>
+            <a:ext cx="10972800" cy="256032"/>
+          </a:xfrm>
+          <a:prstGeom prst="rect">
+            <a:avLst/>
+          </a:prstGeom>
+          <a:noFill/>
+        </p:spPr>
+        <p:txBody>
+          <a:bodyPr wrap="square" lIns="73152" rIns="73152" tIns="36576" bIns="27432" anchor="ctr">
+            <a:spAutoFit/>
+          </a:bodyPr>
+          <a:lstStyle/>
+          <a:p>
+            <a:pPr>
+              <a:defRPr sz="900" b="0">
+                <a:solidFill>
+                  <a:srgbClr val="637389"/>
+                </a:solidFill>
+                <a:latin typeface="Aptos"/>
+              </a:defRPr>
+            </a:pPr>
+            <a:r>
+              <a:t>Görsel belge akışını anlatır; Ollama, model, mevzuat indirme ve klonlama adımları ayrıca onay ister.</a:t>
+            </a:r>
+          </a:p>
+        </p:txBody>
+      </p:sp>
+    </p:spTree>
+  </p:cSld>
+  <p:clrMapOvr>
+    <a:masterClrMapping/>
+  </p:clrMapOvr>
+</p:sld>
+</file>
+
+<file path=ppt/slides/slide24.xml><?xml version="1.0" encoding="utf-8"?>
+<p:sld xmlns:a="http://schemas.openxmlformats.org/drawingml/2006/main" xmlns:p="http://schemas.openxmlformats.org/presentationml/2006/main" xmlns:r="http://schemas.openxmlformats.org/officeDocument/2006/relationships">
+  <p:cSld>
+    <p:bg>
+      <p:bgPr>
+        <a:solidFill>
+          <a:srgbClr val="F7F9FC"/>
+        </a:solidFill>
+        <a:effectLst/>
+      </p:bgPr>
+    </p:bg>
+    <p:spTree>
+      <p:nvGrpSpPr>
+        <p:cNvPr id="1" name=""/>
+        <p:cNvGrpSpPr/>
+        <p:nvPr/>
+      </p:nvGrpSpPr>
+      <p:grpSpPr/>
+      <p:sp>
+        <p:nvSpPr>
+          <p:cNvPr id="2" name="TextBox 1"/>
+          <p:cNvSpPr txBox="1"/>
+          <p:nvPr/>
+        </p:nvSpPr>
+        <p:spPr>
+          <a:xfrm>
+            <a:off x="594360" y="274320"/>
+            <a:ext cx="10972800" cy="228600"/>
+          </a:xfrm>
+          <a:prstGeom prst="rect">
+            <a:avLst/>
+          </a:prstGeom>
+          <a:noFill/>
+        </p:spPr>
+        <p:txBody>
+          <a:bodyPr wrap="square" lIns="73152" rIns="73152" tIns="36576" bIns="27432" anchor="ctr">
+            <a:spAutoFit/>
+          </a:bodyPr>
+          <a:lstStyle/>
+          <a:p>
+            <a:pPr>
+              <a:defRPr sz="1000" b="1">
+                <a:solidFill>
+                  <a:srgbClr val="00AFA0"/>
+                </a:solidFill>
+                <a:latin typeface="Aptos"/>
+              </a:defRPr>
+            </a:pPr>
+            <a:r>
+              <a:t>TEST REPOSU · GERÇEK DOSYA YAPISI</a:t>
+            </a:r>
+          </a:p>
+        </p:txBody>
+      </p:sp>
+      <p:sp>
+        <p:nvSpPr>
+          <p:cNvPr id="3" name="TextBox 2"/>
+          <p:cNvSpPr txBox="1"/>
+          <p:nvPr/>
+        </p:nvSpPr>
+        <p:spPr>
+          <a:xfrm>
+            <a:off x="594360" y="594360"/>
+            <a:ext cx="10972800" cy="502920"/>
+          </a:xfrm>
+          <a:prstGeom prst="rect">
+            <a:avLst/>
+          </a:prstGeom>
+          <a:noFill/>
+        </p:spPr>
+        <p:txBody>
+          <a:bodyPr wrap="square" lIns="73152" rIns="73152" tIns="36576" bIns="27432" anchor="ctr">
+            <a:spAutoFit/>
+          </a:bodyPr>
+          <a:lstStyle/>
+          <a:p>
+            <a:pPr>
+              <a:defRPr sz="2400" b="1">
+                <a:solidFill>
+                  <a:srgbClr val="112240"/>
+                </a:solidFill>
+                <a:latin typeface="Aptos"/>
+              </a:defRPr>
+            </a:pPr>
+            <a:r>
+              <a:t>İki sentetik demo, on test bulgusu</a:t>
+            </a:r>
+          </a:p>
+        </p:txBody>
+      </p:sp>
+      <p:sp>
+        <p:nvSpPr>
+          <p:cNvPr id="4" name="TextBox 3"/>
+          <p:cNvSpPr txBox="1"/>
+          <p:nvPr/>
+        </p:nvSpPr>
+        <p:spPr>
+          <a:xfrm>
+            <a:off x="621792" y="1115568"/>
+            <a:ext cx="10972800" cy="384048"/>
+          </a:xfrm>
+          <a:prstGeom prst="rect">
+            <a:avLst/>
+          </a:prstGeom>
+          <a:noFill/>
+        </p:spPr>
+        <p:txBody>
+          <a:bodyPr wrap="square" lIns="73152" rIns="73152" tIns="36576" bIns="27432" anchor="ctr">
+            <a:spAutoFit/>
+          </a:bodyPr>
+          <a:lstStyle/>
+          <a:p>
+            <a:pPr>
+              <a:defRPr sz="1100" b="0">
+                <a:solidFill>
+                  <a:srgbClr val="637389"/>
+                </a:solidFill>
+                <a:latin typeface="Aptos"/>
+              </a:defRPr>
+            </a:pPr>
+            <a:r>
+              <a:t>Depo ağacı mevcut test fixture Git deposundan; içerik yalnızca test için hazırlanmıştır.</a:t>
+            </a:r>
+          </a:p>
+        </p:txBody>
+      </p:sp>
+      <p:pic>
+        <p:nvPicPr>
+          <p:cNvPr id="5" name="Picture 4" descr="sentetik_test_deposu.png"/>
+          <p:cNvPicPr>
+            <a:picLocks noChangeAspect="1"/>
+          </p:cNvPicPr>
+          <p:nvPr/>
+        </p:nvPicPr>
+        <p:blipFill>
+          <a:blip r:embed="rId2"/>
+          <a:stretch>
+            <a:fillRect/>
+          </a:stretch>
+        </p:blipFill>
+        <p:spPr>
+          <a:xfrm>
+            <a:off x="621792" y="1664208"/>
+            <a:ext cx="10972800" cy="4507992"/>
+          </a:xfrm>
+          <a:prstGeom prst="rect">
+            <a:avLst/>
+          </a:prstGeom>
+        </p:spPr>
+      </p:pic>
+      <p:sp>
+        <p:nvSpPr>
+          <p:cNvPr id="6" name="TextBox 5"/>
+          <p:cNvSpPr txBox="1"/>
+          <p:nvPr/>
+        </p:nvSpPr>
+        <p:spPr>
+          <a:xfrm>
+            <a:off x="685800" y="6263640"/>
+            <a:ext cx="10972800" cy="256032"/>
+          </a:xfrm>
+          <a:prstGeom prst="rect">
+            <a:avLst/>
+          </a:prstGeom>
+          <a:noFill/>
+        </p:spPr>
+        <p:txBody>
+          <a:bodyPr wrap="square" lIns="73152" rIns="73152" tIns="36576" bIns="27432" anchor="ctr">
+            <a:spAutoFit/>
+          </a:bodyPr>
+          <a:lstStyle/>
+          <a:p>
+            <a:pPr>
+              <a:defRPr sz="900" b="0">
+                <a:solidFill>
+                  <a:srgbClr val="637389"/>
+                </a:solidFill>
+                <a:latin typeface="Aptos"/>
+              </a:defRPr>
+            </a:pPr>
+            <a:r>
+              <a:t>Sentetik fixture; gerçek sistem veya gerçek mevzuat bulgusu değildir.</a:t>
+            </a:r>
+          </a:p>
+        </p:txBody>
+      </p:sp>
+    </p:spTree>
+  </p:cSld>
+  <p:clrMapOvr>
+    <a:masterClrMapping/>
+  </p:clrMapOvr>
+</p:sld>
+</file>
+
+<file path=ppt/slides/slide25.xml><?xml version="1.0" encoding="utf-8"?>
+<p:sld xmlns:a="http://schemas.openxmlformats.org/drawingml/2006/main" xmlns:p="http://schemas.openxmlformats.org/presentationml/2006/main" xmlns:r="http://schemas.openxmlformats.org/officeDocument/2006/relationships">
+  <p:cSld>
+    <p:bg>
+      <p:bgPr>
+        <a:solidFill>
+          <a:srgbClr val="F7F9FC"/>
+        </a:solidFill>
+        <a:effectLst/>
+      </p:bgPr>
+    </p:bg>
+    <p:spTree>
+      <p:nvGrpSpPr>
+        <p:cNvPr id="1" name=""/>
+        <p:cNvGrpSpPr/>
+        <p:nvPr/>
+      </p:nvGrpSpPr>
+      <p:grpSpPr/>
+      <p:sp>
+        <p:nvSpPr>
+          <p:cNvPr id="2" name="TextBox 1"/>
+          <p:cNvSpPr txBox="1"/>
+          <p:nvPr/>
+        </p:nvSpPr>
+        <p:spPr>
+          <a:xfrm>
+            <a:off x="594360" y="274320"/>
+            <a:ext cx="10972800" cy="228600"/>
+          </a:xfrm>
+          <a:prstGeom prst="rect">
+            <a:avLst/>
+          </a:prstGeom>
+          <a:noFill/>
+        </p:spPr>
+        <p:txBody>
+          <a:bodyPr wrap="square" lIns="73152" rIns="73152" tIns="36576" bIns="27432" anchor="ctr">
+            <a:spAutoFit/>
+          </a:bodyPr>
+          <a:lstStyle/>
+          <a:p>
+            <a:pPr>
+              <a:defRPr sz="1000" b="1">
+                <a:solidFill>
+                  <a:srgbClr val="00AFA0"/>
+                </a:solidFill>
+                <a:latin typeface="Aptos"/>
+              </a:defRPr>
+            </a:pPr>
+            <a:r>
+              <a:t>REMEDIATION · DIFF + TEST</a:t>
+            </a:r>
+          </a:p>
+        </p:txBody>
+      </p:sp>
+      <p:sp>
+        <p:nvSpPr>
+          <p:cNvPr id="3" name="TextBox 2"/>
+          <p:cNvSpPr txBox="1"/>
+          <p:nvPr/>
+        </p:nvSpPr>
+        <p:spPr>
+          <a:xfrm>
+            <a:off x="594360" y="594360"/>
+            <a:ext cx="10972800" cy="502920"/>
+          </a:xfrm>
+          <a:prstGeom prst="rect">
+            <a:avLst/>
+          </a:prstGeom>
+          <a:noFill/>
+        </p:spPr>
+        <p:txBody>
+          <a:bodyPr wrap="square" lIns="73152" rIns="73152" tIns="36576" bIns="27432" anchor="ctr">
+            <a:spAutoFit/>
+          </a:bodyPr>
+          <a:lstStyle/>
+          <a:p>
+            <a:pPr>
+              <a:defRPr sz="2400" b="1">
+                <a:solidFill>
+                  <a:srgbClr val="112240"/>
+                </a:solidFill>
+                <a:latin typeface="Aptos"/>
+              </a:defRPr>
+            </a:pPr>
+            <a:r>
+              <a:t>Önce / sonra farkı ve kabul testi</a:t>
+            </a:r>
+          </a:p>
+        </p:txBody>
+      </p:sp>
+      <p:sp>
+        <p:nvSpPr>
+          <p:cNvPr id="4" name="TextBox 3"/>
+          <p:cNvSpPr txBox="1"/>
+          <p:nvPr/>
+        </p:nvSpPr>
+        <p:spPr>
+          <a:xfrm>
+            <a:off x="621792" y="1115568"/>
+            <a:ext cx="10972800" cy="384048"/>
+          </a:xfrm>
+          <a:prstGeom prst="rect">
+            <a:avLst/>
+          </a:prstGeom>
+          <a:noFill/>
+        </p:spPr>
+        <p:txBody>
+          <a:bodyPr wrap="square" lIns="73152" rIns="73152" tIns="36576" bIns="27432" anchor="ctr">
+            <a:spAutoFit/>
+          </a:bodyPr>
+          <a:lstStyle/>
+          <a:p>
+            <a:pPr>
+              <a:defRPr sz="1100" b="0">
+                <a:solidFill>
+                  <a:srgbClr val="637389"/>
+                </a:solidFill>
+                <a:latin typeface="Aptos"/>
+              </a:defRPr>
+            </a:pPr>
+            <a:r>
+              <a:t>Görsel, izole remediation worktree raporundaki iki örnek değişikliği ve test raporunu gösterir.</a:t>
+            </a:r>
+          </a:p>
+        </p:txBody>
+      </p:sp>
+      <p:pic>
+        <p:nvPicPr>
+          <p:cNvPr id="5" name="Picture 4" descr="remediation_diff_ve_test.png"/>
+          <p:cNvPicPr>
+            <a:picLocks noChangeAspect="1"/>
+          </p:cNvPicPr>
+          <p:nvPr/>
+        </p:nvPicPr>
+        <p:blipFill>
+          <a:blip r:embed="rId2"/>
+          <a:stretch>
+            <a:fillRect/>
+          </a:stretch>
+        </p:blipFill>
+        <p:spPr>
+          <a:xfrm>
+            <a:off x="621792" y="1664208"/>
+            <a:ext cx="10972800" cy="4507992"/>
+          </a:xfrm>
+          <a:prstGeom prst="rect">
+            <a:avLst/>
+          </a:prstGeom>
+        </p:spPr>
+      </p:pic>
+      <p:sp>
+        <p:nvSpPr>
+          <p:cNvPr id="6" name="TextBox 5"/>
+          <p:cNvSpPr txBox="1"/>
+          <p:nvPr/>
+        </p:nvSpPr>
+        <p:spPr>
+          <a:xfrm>
+            <a:off x="685800" y="6263640"/>
+            <a:ext cx="10972800" cy="256032"/>
+          </a:xfrm>
+          <a:prstGeom prst="rect">
+            <a:avLst/>
+          </a:prstGeom>
+          <a:noFill/>
+        </p:spPr>
+        <p:txBody>
+          <a:bodyPr wrap="square" lIns="73152" rIns="73152" tIns="36576" bIns="27432" anchor="ctr">
+            <a:spAutoFit/>
+          </a:bodyPr>
+          <a:lstStyle/>
+          <a:p>
+            <a:pPr>
+              <a:defRPr sz="900" b="0">
+                <a:solidFill>
+                  <a:srgbClr val="637389"/>
+                </a:solidFill>
+                <a:latin typeface="Aptos"/>
+              </a:defRPr>
+            </a:pPr>
+            <a:r>
+              <a:t>Test raporunda 2 sentetik kabul testi geçti; hukuki uyumluluk doğrulaması değildir.</a:t>
+            </a:r>
+          </a:p>
+        </p:txBody>
+      </p:sp>
+    </p:spTree>
+  </p:cSld>
+  <p:clrMapOvr>
+    <a:masterClrMapping/>
+  </p:clrMapOvr>
+</p:sld>
+</file>
+
+<file path=ppt/slides/slide26.xml><?xml version="1.0" encoding="utf-8"?>
+<p:sld xmlns:a="http://schemas.openxmlformats.org/drawingml/2006/main" xmlns:p="http://schemas.openxmlformats.org/presentationml/2006/main" xmlns:r="http://schemas.openxmlformats.org/officeDocument/2006/relationships">
+  <p:cSld>
+    <p:bg>
+      <p:bgPr>
+        <a:solidFill>
+          <a:srgbClr val="F7F9FC"/>
+        </a:solidFill>
+        <a:effectLst/>
+      </p:bgPr>
+    </p:bg>
+    <p:spTree>
+      <p:nvGrpSpPr>
+        <p:cNvPr id="1" name=""/>
+        <p:cNvGrpSpPr/>
+        <p:nvPr/>
+      </p:nvGrpSpPr>
+      <p:grpSpPr/>
+      <p:sp>
+        <p:nvSpPr>
+          <p:cNvPr id="2" name="TextBox 1"/>
+          <p:cNvSpPr txBox="1"/>
+          <p:nvPr/>
+        </p:nvSpPr>
+        <p:spPr>
+          <a:xfrm>
+            <a:off x="594360" y="274320"/>
+            <a:ext cx="10972800" cy="228600"/>
+          </a:xfrm>
+          <a:prstGeom prst="rect">
+            <a:avLst/>
+          </a:prstGeom>
+          <a:noFill/>
+        </p:spPr>
+        <p:txBody>
+          <a:bodyPr wrap="square" lIns="73152" rIns="73152" tIns="36576" bIns="27432" anchor="ctr">
+            <a:spAutoFit/>
+          </a:bodyPr>
+          <a:lstStyle/>
+          <a:p>
+            <a:pPr>
+              <a:defRPr sz="1000" b="1">
+                <a:solidFill>
+                  <a:srgbClr val="00AFA0"/>
+                </a:solidFill>
+                <a:latin typeface="Aptos"/>
+              </a:defRPr>
+            </a:pPr>
+            <a:r>
+              <a:t>PR · YEREL ENTEGRASYON PROVASI</a:t>
+            </a:r>
+          </a:p>
+        </p:txBody>
+      </p:sp>
+      <p:sp>
+        <p:nvSpPr>
+          <p:cNvPr id="3" name="TextBox 2"/>
+          <p:cNvSpPr txBox="1"/>
+          <p:nvPr/>
+        </p:nvSpPr>
+        <p:spPr>
+          <a:xfrm>
+            <a:off x="594360" y="594360"/>
+            <a:ext cx="10972800" cy="502920"/>
+          </a:xfrm>
+          <a:prstGeom prst="rect">
+            <a:avLst/>
+          </a:prstGeom>
+          <a:noFill/>
+        </p:spPr>
+        <p:txBody>
+          <a:bodyPr wrap="square" lIns="73152" rIns="73152" tIns="36576" bIns="27432" anchor="ctr">
+            <a:spAutoFit/>
+          </a:bodyPr>
+          <a:lstStyle/>
+          <a:p>
+            <a:pPr>
+              <a:defRPr sz="2400" b="1">
+                <a:solidFill>
+                  <a:srgbClr val="112240"/>
+                </a:solidFill>
+                <a:latin typeface="Aptos"/>
+              </a:defRPr>
+            </a:pPr>
+            <a:r>
+              <a:t>Push/PR hattı güvenli test ortamında denendi</a:t>
+            </a:r>
+          </a:p>
+        </p:txBody>
+      </p:sp>
+      <p:sp>
+        <p:nvSpPr>
+          <p:cNvPr id="4" name="TextBox 3"/>
+          <p:cNvSpPr txBox="1"/>
+          <p:nvPr/>
+        </p:nvSpPr>
+        <p:spPr>
+          <a:xfrm>
+            <a:off x="621792" y="1115568"/>
+            <a:ext cx="10972800" cy="384048"/>
+          </a:xfrm>
+          <a:prstGeom prst="rect">
+            <a:avLst/>
+          </a:prstGeom>
+          <a:noFill/>
+        </p:spPr>
+        <p:txBody>
+          <a:bodyPr wrap="square" lIns="73152" rIns="73152" tIns="36576" bIns="27432" anchor="ctr">
+            <a:spAutoFit/>
+          </a:bodyPr>
+          <a:lstStyle/>
+          <a:p>
+            <a:pPr>
+              <a:defRPr sz="1100" b="0">
+                <a:solidFill>
+                  <a:srgbClr val="637389"/>
+                </a:solidFill>
+                <a:latin typeface="Aptos"/>
+              </a:defRPr>
+            </a:pPr>
+            <a:r>
+              <a:t>Yerel bare Git remote ve fake gh kullanıldı; gerçek GitHub PR açılmadı.</a:t>
+            </a:r>
+          </a:p>
+        </p:txBody>
+      </p:sp>
+      <p:pic>
+        <p:nvPicPr>
+          <p:cNvPr id="5" name="Picture 4" descr="pr_akisi_yerel_prova.png"/>
+          <p:cNvPicPr>
+            <a:picLocks noChangeAspect="1"/>
+          </p:cNvPicPr>
+          <p:nvPr/>
+        </p:nvPicPr>
+        <p:blipFill>
+          <a:blip r:embed="rId2"/>
+          <a:stretch>
+            <a:fillRect/>
+          </a:stretch>
+        </p:blipFill>
+        <p:spPr>
+          <a:xfrm>
+            <a:off x="621792" y="1664208"/>
+            <a:ext cx="10972800" cy="4507992"/>
+          </a:xfrm>
+          <a:prstGeom prst="rect">
+            <a:avLst/>
+          </a:prstGeom>
+        </p:spPr>
+      </p:pic>
+      <p:sp>
+        <p:nvSpPr>
+          <p:cNvPr id="6" name="TextBox 5"/>
+          <p:cNvSpPr txBox="1"/>
+          <p:nvPr/>
+        </p:nvSpPr>
+        <p:spPr>
+          <a:xfrm>
+            <a:off x="685800" y="6263640"/>
+            <a:ext cx="10972800" cy="256032"/>
+          </a:xfrm>
+          <a:prstGeom prst="rect">
+            <a:avLst/>
+          </a:prstGeom>
+          <a:noFill/>
+        </p:spPr>
+        <p:txBody>
+          <a:bodyPr wrap="square" lIns="73152" rIns="73152" tIns="36576" bIns="27432" anchor="ctr">
+            <a:spAutoFit/>
+          </a:bodyPr>
+          <a:lstStyle/>
+          <a:p>
+            <a:pPr>
+              <a:defRPr sz="900" b="0">
+                <a:solidFill>
+                  <a:srgbClr val="637389"/>
+                </a:solidFill>
+                <a:latin typeface="Aptos"/>
+              </a:defRPr>
+            </a:pPr>
+            <a:r>
+              <a:t>Gerçek PR ekran görüntüsü mevcut değildir; bu görsel yerel mock provayı açıkça etiketler.</a:t>
+            </a:r>
+          </a:p>
+        </p:txBody>
+      </p:sp>
+    </p:spTree>
+  </p:cSld>
+  <p:clrMapOvr>
+    <a:masterClrMapping/>
+  </p:clrMapOvr>
+</p:sld>
+</file>
+
 <file path=ppt/slides/slide3.xml><?xml version="1.0" encoding="utf-8"?>
 <p:sld xmlns:a="http://schemas.openxmlformats.org/drawingml/2006/main" xmlns:p="http://schemas.openxmlformats.org/presentationml/2006/main" xmlns:r="http://schemas.openxmlformats.org/officeDocument/2006/relationships">
   <p:cSld>

</xml_diff>

<commit_message>
Use official Softtech branding in public project
Co-authored-by: Copilot <223556219+Copilot@users.noreply.github.com>
</commit_message>
<xml_diff>
--- a/docs/MevzuAI_Sunum_Guncel.pptx
+++ b/docs/MevzuAI_Sunum_Guncel.pptx
@@ -3771,6 +3771,30 @@
           </a:p>
         </p:txBody>
       </p:sp>
+      <p:pic>
+        <p:nvPicPr>
+          <p:cNvPr id="16" name="Picture 15" descr="softtech-logo.png"/>
+          <p:cNvPicPr>
+            <a:picLocks noChangeAspect="1"/>
+          </p:cNvPicPr>
+          <p:nvPr/>
+        </p:nvPicPr>
+        <p:blipFill>
+          <a:blip r:embed="rId3"/>
+          <a:stretch>
+            <a:fillRect/>
+          </a:stretch>
+        </p:blipFill>
+        <p:spPr>
+          <a:xfrm>
+            <a:off x="9189720" y="5330952"/>
+            <a:ext cx="2148840" cy="932738"/>
+          </a:xfrm>
+          <a:prstGeom prst="rect">
+            <a:avLst/>
+          </a:prstGeom>
+        </p:spPr>
+      </p:pic>
     </p:spTree>
   </p:cSld>
   <p:clrMapOvr>
@@ -6027,6 +6051,30 @@
           </a:p>
         </p:txBody>
       </p:sp>
+      <p:pic>
+        <p:nvPicPr>
+          <p:cNvPr id="53" name="Picture 52" descr="softtech-logo.png"/>
+          <p:cNvPicPr>
+            <a:picLocks noChangeAspect="1"/>
+          </p:cNvPicPr>
+          <p:nvPr/>
+        </p:nvPicPr>
+        <p:blipFill>
+          <a:blip r:embed="rId3"/>
+          <a:stretch>
+            <a:fillRect/>
+          </a:stretch>
+        </p:blipFill>
+        <p:spPr>
+          <a:xfrm>
+            <a:off x="9985248" y="6382512"/>
+            <a:ext cx="960120" cy="416755"/>
+          </a:xfrm>
+          <a:prstGeom prst="rect">
+            <a:avLst/>
+          </a:prstGeom>
+        </p:spPr>
+      </p:pic>
     </p:spTree>
   </p:cSld>
   <p:clrMapOvr>
@@ -7286,6 +7334,30 @@
           </a:p>
         </p:txBody>
       </p:sp>
+      <p:pic>
+        <p:nvPicPr>
+          <p:cNvPr id="26" name="Picture 25" descr="softtech-logo.png"/>
+          <p:cNvPicPr>
+            <a:picLocks noChangeAspect="1"/>
+          </p:cNvPicPr>
+          <p:nvPr/>
+        </p:nvPicPr>
+        <p:blipFill>
+          <a:blip r:embed="rId3"/>
+          <a:stretch>
+            <a:fillRect/>
+          </a:stretch>
+        </p:blipFill>
+        <p:spPr>
+          <a:xfrm>
+            <a:off x="9985248" y="6382512"/>
+            <a:ext cx="960120" cy="416755"/>
+          </a:xfrm>
+          <a:prstGeom prst="rect">
+            <a:avLst/>
+          </a:prstGeom>
+        </p:spPr>
+      </p:pic>
     </p:spTree>
   </p:cSld>
   <p:clrMapOvr>
@@ -8346,6 +8418,30 @@
           </a:p>
         </p:txBody>
       </p:sp>
+      <p:pic>
+        <p:nvPicPr>
+          <p:cNvPr id="26" name="Picture 25" descr="softtech-logo.png"/>
+          <p:cNvPicPr>
+            <a:picLocks noChangeAspect="1"/>
+          </p:cNvPicPr>
+          <p:nvPr/>
+        </p:nvPicPr>
+        <p:blipFill>
+          <a:blip r:embed="rId3"/>
+          <a:stretch>
+            <a:fillRect/>
+          </a:stretch>
+        </p:blipFill>
+        <p:spPr>
+          <a:xfrm>
+            <a:off x="9985248" y="6382512"/>
+            <a:ext cx="960120" cy="416755"/>
+          </a:xfrm>
+          <a:prstGeom prst="rect">
+            <a:avLst/>
+          </a:prstGeom>
+        </p:spPr>
+      </p:pic>
     </p:spTree>
   </p:cSld>
   <p:clrMapOvr>
@@ -9621,6 +9717,30 @@
           </a:p>
         </p:txBody>
       </p:sp>
+      <p:pic>
+        <p:nvPicPr>
+          <p:cNvPr id="26" name="Picture 25" descr="softtech-logo.png"/>
+          <p:cNvPicPr>
+            <a:picLocks noChangeAspect="1"/>
+          </p:cNvPicPr>
+          <p:nvPr/>
+        </p:nvPicPr>
+        <p:blipFill>
+          <a:blip r:embed="rId3"/>
+          <a:stretch>
+            <a:fillRect/>
+          </a:stretch>
+        </p:blipFill>
+        <p:spPr>
+          <a:xfrm>
+            <a:off x="9985248" y="6382512"/>
+            <a:ext cx="960120" cy="416755"/>
+          </a:xfrm>
+          <a:prstGeom prst="rect">
+            <a:avLst/>
+          </a:prstGeom>
+        </p:spPr>
+      </p:pic>
     </p:spTree>
   </p:cSld>
   <p:clrMapOvr>
@@ -10594,6 +10714,30 @@
           </a:p>
         </p:txBody>
       </p:sp>
+      <p:pic>
+        <p:nvPicPr>
+          <p:cNvPr id="25" name="Picture 24" descr="softtech-logo.png"/>
+          <p:cNvPicPr>
+            <a:picLocks noChangeAspect="1"/>
+          </p:cNvPicPr>
+          <p:nvPr/>
+        </p:nvPicPr>
+        <p:blipFill>
+          <a:blip r:embed="rId3"/>
+          <a:stretch>
+            <a:fillRect/>
+          </a:stretch>
+        </p:blipFill>
+        <p:spPr>
+          <a:xfrm>
+            <a:off x="9985248" y="6382512"/>
+            <a:ext cx="960120" cy="416755"/>
+          </a:xfrm>
+          <a:prstGeom prst="rect">
+            <a:avLst/>
+          </a:prstGeom>
+        </p:spPr>
+      </p:pic>
     </p:spTree>
   </p:cSld>
   <p:clrMapOvr>
@@ -11138,6 +11282,30 @@
           </a:p>
         </p:txBody>
       </p:sp>
+      <p:pic>
+        <p:nvPicPr>
+          <p:cNvPr id="15" name="Picture 14" descr="softtech-logo.png"/>
+          <p:cNvPicPr>
+            <a:picLocks noChangeAspect="1"/>
+          </p:cNvPicPr>
+          <p:nvPr/>
+        </p:nvPicPr>
+        <p:blipFill>
+          <a:blip r:embed="rId5"/>
+          <a:stretch>
+            <a:fillRect/>
+          </a:stretch>
+        </p:blipFill>
+        <p:spPr>
+          <a:xfrm>
+            <a:off x="9985248" y="6382512"/>
+            <a:ext cx="960120" cy="416755"/>
+          </a:xfrm>
+          <a:prstGeom prst="rect">
+            <a:avLst/>
+          </a:prstGeom>
+        </p:spPr>
+      </p:pic>
     </p:spTree>
   </p:cSld>
   <p:clrMapOvr>
@@ -12313,6 +12481,30 @@
           </a:p>
         </p:txBody>
       </p:sp>
+      <p:pic>
+        <p:nvPicPr>
+          <p:cNvPr id="28" name="Picture 27" descr="softtech-logo.png"/>
+          <p:cNvPicPr>
+            <a:picLocks noChangeAspect="1"/>
+          </p:cNvPicPr>
+          <p:nvPr/>
+        </p:nvPicPr>
+        <p:blipFill>
+          <a:blip r:embed="rId3"/>
+          <a:stretch>
+            <a:fillRect/>
+          </a:stretch>
+        </p:blipFill>
+        <p:spPr>
+          <a:xfrm>
+            <a:off x="9985248" y="6382512"/>
+            <a:ext cx="960120" cy="416755"/>
+          </a:xfrm>
+          <a:prstGeom prst="rect">
+            <a:avLst/>
+          </a:prstGeom>
+        </p:spPr>
+      </p:pic>
     </p:spTree>
   </p:cSld>
   <p:clrMapOvr>
@@ -15259,6 +15451,30 @@
           </a:p>
         </p:txBody>
       </p:sp>
+      <p:pic>
+        <p:nvPicPr>
+          <p:cNvPr id="77" name="Picture 76" descr="softtech-logo.png"/>
+          <p:cNvPicPr>
+            <a:picLocks noChangeAspect="1"/>
+          </p:cNvPicPr>
+          <p:nvPr/>
+        </p:nvPicPr>
+        <p:blipFill>
+          <a:blip r:embed="rId3"/>
+          <a:stretch>
+            <a:fillRect/>
+          </a:stretch>
+        </p:blipFill>
+        <p:spPr>
+          <a:xfrm>
+            <a:off x="9985248" y="6382512"/>
+            <a:ext cx="960120" cy="416755"/>
+          </a:xfrm>
+          <a:prstGeom prst="rect">
+            <a:avLst/>
+          </a:prstGeom>
+        </p:spPr>
+      </p:pic>
     </p:spTree>
   </p:cSld>
   <p:clrMapOvr>
@@ -16018,6 +16234,30 @@
           </a:p>
         </p:txBody>
       </p:sp>
+      <p:pic>
+        <p:nvPicPr>
+          <p:cNvPr id="20" name="Picture 19" descr="softtech-logo.png"/>
+          <p:cNvPicPr>
+            <a:picLocks noChangeAspect="1"/>
+          </p:cNvPicPr>
+          <p:nvPr/>
+        </p:nvPicPr>
+        <p:blipFill>
+          <a:blip r:embed="rId3"/>
+          <a:stretch>
+            <a:fillRect/>
+          </a:stretch>
+        </p:blipFill>
+        <p:spPr>
+          <a:xfrm>
+            <a:off x="9985248" y="6382512"/>
+            <a:ext cx="960120" cy="416755"/>
+          </a:xfrm>
+          <a:prstGeom prst="rect">
+            <a:avLst/>
+          </a:prstGeom>
+        </p:spPr>
+      </p:pic>
     </p:spTree>
   </p:cSld>
   <p:clrMapOvr>
@@ -16425,6 +16665,30 @@
           </a:p>
         </p:txBody>
       </p:sp>
+      <p:pic>
+        <p:nvPicPr>
+          <p:cNvPr id="10" name="Picture 9" descr="softtech-logo.png"/>
+          <p:cNvPicPr>
+            <a:picLocks noChangeAspect="1"/>
+          </p:cNvPicPr>
+          <p:nvPr/>
+        </p:nvPicPr>
+        <p:blipFill>
+          <a:blip r:embed="rId3"/>
+          <a:stretch>
+            <a:fillRect/>
+          </a:stretch>
+        </p:blipFill>
+        <p:spPr>
+          <a:xfrm>
+            <a:off x="9985248" y="6382512"/>
+            <a:ext cx="960120" cy="416755"/>
+          </a:xfrm>
+          <a:prstGeom prst="rect">
+            <a:avLst/>
+          </a:prstGeom>
+        </p:spPr>
+      </p:pic>
     </p:spTree>
   </p:cSld>
   <p:clrMapOvr>
@@ -17144,6 +17408,30 @@
           </a:p>
         </p:txBody>
       </p:sp>
+      <p:pic>
+        <p:nvPicPr>
+          <p:cNvPr id="16" name="Picture 15" descr="softtech-logo.png"/>
+          <p:cNvPicPr>
+            <a:picLocks noChangeAspect="1"/>
+          </p:cNvPicPr>
+          <p:nvPr/>
+        </p:nvPicPr>
+        <p:blipFill>
+          <a:blip r:embed="rId3"/>
+          <a:stretch>
+            <a:fillRect/>
+          </a:stretch>
+        </p:blipFill>
+        <p:spPr>
+          <a:xfrm>
+            <a:off x="9985248" y="6382512"/>
+            <a:ext cx="960120" cy="416755"/>
+          </a:xfrm>
+          <a:prstGeom prst="rect">
+            <a:avLst/>
+          </a:prstGeom>
+        </p:spPr>
+      </p:pic>
     </p:spTree>
   </p:cSld>
   <p:clrMapOvr>
@@ -18123,6 +18411,30 @@
           </a:p>
         </p:txBody>
       </p:sp>
+      <p:pic>
+        <p:nvPicPr>
+          <p:cNvPr id="26" name="Picture 25" descr="softtech-logo.png"/>
+          <p:cNvPicPr>
+            <a:picLocks noChangeAspect="1"/>
+          </p:cNvPicPr>
+          <p:nvPr/>
+        </p:nvPicPr>
+        <p:blipFill>
+          <a:blip r:embed="rId2"/>
+          <a:stretch>
+            <a:fillRect/>
+          </a:stretch>
+        </p:blipFill>
+        <p:spPr>
+          <a:xfrm>
+            <a:off x="9985248" y="6382512"/>
+            <a:ext cx="960120" cy="416755"/>
+          </a:xfrm>
+          <a:prstGeom prst="rect">
+            <a:avLst/>
+          </a:prstGeom>
+        </p:spPr>
+      </p:pic>
     </p:spTree>
   </p:cSld>
   <p:clrMapOvr>
@@ -18764,6 +19076,30 @@
           </a:p>
         </p:txBody>
       </p:sp>
+      <p:pic>
+        <p:nvPicPr>
+          <p:cNvPr id="7" name="Picture 6" descr="softtech-logo.png"/>
+          <p:cNvPicPr>
+            <a:picLocks noChangeAspect="1"/>
+          </p:cNvPicPr>
+          <p:nvPr/>
+        </p:nvPicPr>
+        <p:blipFill>
+          <a:blip r:embed="rId2"/>
+          <a:stretch>
+            <a:fillRect/>
+          </a:stretch>
+        </p:blipFill>
+        <p:spPr>
+          <a:xfrm>
+            <a:off x="9985248" y="6382512"/>
+            <a:ext cx="960120" cy="416755"/>
+          </a:xfrm>
+          <a:prstGeom prst="rect">
+            <a:avLst/>
+          </a:prstGeom>
+        </p:spPr>
+      </p:pic>
     </p:spTree>
   </p:cSld>
   <p:clrMapOvr>
@@ -19526,6 +19862,30 @@
           </a:p>
         </p:txBody>
       </p:sp>
+      <p:pic>
+        <p:nvPicPr>
+          <p:cNvPr id="20" name="Picture 19" descr="softtech-logo.png"/>
+          <p:cNvPicPr>
+            <a:picLocks noChangeAspect="1"/>
+          </p:cNvPicPr>
+          <p:nvPr/>
+        </p:nvPicPr>
+        <p:blipFill>
+          <a:blip r:embed="rId2"/>
+          <a:stretch>
+            <a:fillRect/>
+          </a:stretch>
+        </p:blipFill>
+        <p:spPr>
+          <a:xfrm>
+            <a:off x="9985248" y="6382512"/>
+            <a:ext cx="960120" cy="416755"/>
+          </a:xfrm>
+          <a:prstGeom prst="rect">
+            <a:avLst/>
+          </a:prstGeom>
+        </p:spPr>
+      </p:pic>
     </p:spTree>
   </p:cSld>
   <p:clrMapOvr>
@@ -19677,7 +20037,7 @@
         <p:spPr>
           <a:xfrm>
             <a:off x="621792" y="1664208"/>
-            <a:ext cx="10972800" cy="4507992"/>
+            <a:ext cx="10972800" cy="4315968"/>
           </a:xfrm>
           <a:prstGeom prst="rect">
             <a:avLst/>
@@ -19692,8 +20052,8 @@
         </p:nvSpPr>
         <p:spPr>
           <a:xfrm>
-            <a:off x="685800" y="6263640"/>
-            <a:ext cx="10972800" cy="256032"/>
+            <a:off x="685800" y="6071616"/>
+            <a:ext cx="9235440" cy="402336"/>
           </a:xfrm>
           <a:prstGeom prst="rect">
             <a:avLst/>
@@ -19720,6 +20080,30 @@
           </a:p>
         </p:txBody>
       </p:sp>
+      <p:pic>
+        <p:nvPicPr>
+          <p:cNvPr id="7" name="Picture 6" descr="softtech-logo.png"/>
+          <p:cNvPicPr>
+            <a:picLocks noChangeAspect="1"/>
+          </p:cNvPicPr>
+          <p:nvPr/>
+        </p:nvPicPr>
+        <p:blipFill>
+          <a:blip r:embed="rId3"/>
+          <a:stretch>
+            <a:fillRect/>
+          </a:stretch>
+        </p:blipFill>
+        <p:spPr>
+          <a:xfrm>
+            <a:off x="9985248" y="6382512"/>
+            <a:ext cx="960120" cy="416755"/>
+          </a:xfrm>
+          <a:prstGeom prst="rect">
+            <a:avLst/>
+          </a:prstGeom>
+        </p:spPr>
+      </p:pic>
     </p:spTree>
   </p:cSld>
   <p:clrMapOvr>
@@ -19871,7 +20255,7 @@
         <p:spPr>
           <a:xfrm>
             <a:off x="621792" y="1664208"/>
-            <a:ext cx="10972800" cy="4507992"/>
+            <a:ext cx="10972800" cy="4315968"/>
           </a:xfrm>
           <a:prstGeom prst="rect">
             <a:avLst/>
@@ -19886,8 +20270,8 @@
         </p:nvSpPr>
         <p:spPr>
           <a:xfrm>
-            <a:off x="685800" y="6263640"/>
-            <a:ext cx="10972800" cy="256032"/>
+            <a:off x="685800" y="6071616"/>
+            <a:ext cx="9235440" cy="402336"/>
           </a:xfrm>
           <a:prstGeom prst="rect">
             <a:avLst/>
@@ -19914,6 +20298,30 @@
           </a:p>
         </p:txBody>
       </p:sp>
+      <p:pic>
+        <p:nvPicPr>
+          <p:cNvPr id="7" name="Picture 6" descr="softtech-logo.png"/>
+          <p:cNvPicPr>
+            <a:picLocks noChangeAspect="1"/>
+          </p:cNvPicPr>
+          <p:nvPr/>
+        </p:nvPicPr>
+        <p:blipFill>
+          <a:blip r:embed="rId3"/>
+          <a:stretch>
+            <a:fillRect/>
+          </a:stretch>
+        </p:blipFill>
+        <p:spPr>
+          <a:xfrm>
+            <a:off x="9985248" y="6382512"/>
+            <a:ext cx="960120" cy="416755"/>
+          </a:xfrm>
+          <a:prstGeom prst="rect">
+            <a:avLst/>
+          </a:prstGeom>
+        </p:spPr>
+      </p:pic>
     </p:spTree>
   </p:cSld>
   <p:clrMapOvr>
@@ -20065,7 +20473,7 @@
         <p:spPr>
           <a:xfrm>
             <a:off x="621792" y="1664208"/>
-            <a:ext cx="10972800" cy="4507992"/>
+            <a:ext cx="10972800" cy="4315968"/>
           </a:xfrm>
           <a:prstGeom prst="rect">
             <a:avLst/>
@@ -20080,8 +20488,8 @@
         </p:nvSpPr>
         <p:spPr>
           <a:xfrm>
-            <a:off x="685800" y="6263640"/>
-            <a:ext cx="10972800" cy="256032"/>
+            <a:off x="685800" y="6071616"/>
+            <a:ext cx="9235440" cy="402336"/>
           </a:xfrm>
           <a:prstGeom prst="rect">
             <a:avLst/>
@@ -20108,6 +20516,30 @@
           </a:p>
         </p:txBody>
       </p:sp>
+      <p:pic>
+        <p:nvPicPr>
+          <p:cNvPr id="7" name="Picture 6" descr="softtech-logo.png"/>
+          <p:cNvPicPr>
+            <a:picLocks noChangeAspect="1"/>
+          </p:cNvPicPr>
+          <p:nvPr/>
+        </p:nvPicPr>
+        <p:blipFill>
+          <a:blip r:embed="rId3"/>
+          <a:stretch>
+            <a:fillRect/>
+          </a:stretch>
+        </p:blipFill>
+        <p:spPr>
+          <a:xfrm>
+            <a:off x="9985248" y="6382512"/>
+            <a:ext cx="960120" cy="416755"/>
+          </a:xfrm>
+          <a:prstGeom prst="rect">
+            <a:avLst/>
+          </a:prstGeom>
+        </p:spPr>
+      </p:pic>
     </p:spTree>
   </p:cSld>
   <p:clrMapOvr>
@@ -20259,7 +20691,7 @@
         <p:spPr>
           <a:xfrm>
             <a:off x="621792" y="1664208"/>
-            <a:ext cx="10972800" cy="4507992"/>
+            <a:ext cx="10972800" cy="4315968"/>
           </a:xfrm>
           <a:prstGeom prst="rect">
             <a:avLst/>
@@ -20274,8 +20706,8 @@
         </p:nvSpPr>
         <p:spPr>
           <a:xfrm>
-            <a:off x="685800" y="6263640"/>
-            <a:ext cx="10972800" cy="256032"/>
+            <a:off x="685800" y="6071616"/>
+            <a:ext cx="9235440" cy="402336"/>
           </a:xfrm>
           <a:prstGeom prst="rect">
             <a:avLst/>
@@ -20298,6 +20730,66 @@
             </a:pPr>
             <a:r>
               <a:t>Gerçek PR ekran görüntüsü mevcut değildir; bu görsel yerel mock provayı açıkça etiketler.</a:t>
+            </a:r>
+          </a:p>
+        </p:txBody>
+      </p:sp>
+      <p:pic>
+        <p:nvPicPr>
+          <p:cNvPr id="7" name="Picture 6" descr="softtech-logo.png"/>
+          <p:cNvPicPr>
+            <a:picLocks noChangeAspect="1"/>
+          </p:cNvPicPr>
+          <p:nvPr/>
+        </p:nvPicPr>
+        <p:blipFill>
+          <a:blip r:embed="rId3"/>
+          <a:stretch>
+            <a:fillRect/>
+          </a:stretch>
+        </p:blipFill>
+        <p:spPr>
+          <a:xfrm>
+            <a:off x="9985248" y="6382512"/>
+            <a:ext cx="960120" cy="416755"/>
+          </a:xfrm>
+          <a:prstGeom prst="rect">
+            <a:avLst/>
+          </a:prstGeom>
+        </p:spPr>
+      </p:pic>
+      <p:sp>
+        <p:nvSpPr>
+          <p:cNvPr id="8" name="TextBox 7"/>
+          <p:cNvSpPr txBox="1"/>
+          <p:nvPr/>
+        </p:nvSpPr>
+        <p:spPr>
+          <a:xfrm>
+            <a:off x="685800" y="5742432"/>
+            <a:ext cx="9052560" cy="274320"/>
+          </a:xfrm>
+          <a:prstGeom prst="rect">
+            <a:avLst/>
+          </a:prstGeom>
+          <a:noFill/>
+        </p:spPr>
+        <p:txBody>
+          <a:bodyPr wrap="square" lIns="73152" rIns="73152" tIns="36576" bIns="27432" anchor="ctr">
+            <a:spAutoFit/>
+          </a:bodyPr>
+          <a:lstStyle/>
+          <a:p>
+            <a:pPr>
+              <a:defRPr sz="900" b="0">
+                <a:solidFill>
+                  <a:srgbClr val="637389"/>
+                </a:solidFill>
+                <a:latin typeface="Aptos"/>
+              </a:defRPr>
+            </a:pPr>
+            <a:r>
+              <a:t>Softtech logosu görsel amaçlıdır; kurumsal onay veya iş birliği beyanı değildir.</a:t>
             </a:r>
           </a:p>
         </p:txBody>
@@ -22622,6 +23114,30 @@
           </a:p>
         </p:txBody>
       </p:sp>
+      <p:pic>
+        <p:nvPicPr>
+          <p:cNvPr id="57" name="Picture 56" descr="softtech-logo.png"/>
+          <p:cNvPicPr>
+            <a:picLocks noChangeAspect="1"/>
+          </p:cNvPicPr>
+          <p:nvPr/>
+        </p:nvPicPr>
+        <p:blipFill>
+          <a:blip r:embed="rId3"/>
+          <a:stretch>
+            <a:fillRect/>
+          </a:stretch>
+        </p:blipFill>
+        <p:spPr>
+          <a:xfrm>
+            <a:off x="9985248" y="6382512"/>
+            <a:ext cx="960120" cy="416755"/>
+          </a:xfrm>
+          <a:prstGeom prst="rect">
+            <a:avLst/>
+          </a:prstGeom>
+        </p:spPr>
+      </p:pic>
     </p:spTree>
   </p:cSld>
   <p:clrMapOvr>
@@ -23474,6 +23990,30 @@
           </a:p>
         </p:txBody>
       </p:sp>
+      <p:pic>
+        <p:nvPicPr>
+          <p:cNvPr id="18" name="Picture 17" descr="softtech-logo.png"/>
+          <p:cNvPicPr>
+            <a:picLocks noChangeAspect="1"/>
+          </p:cNvPicPr>
+          <p:nvPr/>
+        </p:nvPicPr>
+        <p:blipFill>
+          <a:blip r:embed="rId3"/>
+          <a:stretch>
+            <a:fillRect/>
+          </a:stretch>
+        </p:blipFill>
+        <p:spPr>
+          <a:xfrm>
+            <a:off x="9985248" y="6382512"/>
+            <a:ext cx="960120" cy="416755"/>
+          </a:xfrm>
+          <a:prstGeom prst="rect">
+            <a:avLst/>
+          </a:prstGeom>
+        </p:spPr>
+      </p:pic>
     </p:spTree>
   </p:cSld>
   <p:clrMapOvr>
@@ -24278,6 +24818,30 @@
           </a:p>
         </p:txBody>
       </p:sp>
+      <p:pic>
+        <p:nvPicPr>
+          <p:cNvPr id="18" name="Picture 17" descr="softtech-logo.png"/>
+          <p:cNvPicPr>
+            <a:picLocks noChangeAspect="1"/>
+          </p:cNvPicPr>
+          <p:nvPr/>
+        </p:nvPicPr>
+        <p:blipFill>
+          <a:blip r:embed="rId3"/>
+          <a:stretch>
+            <a:fillRect/>
+          </a:stretch>
+        </p:blipFill>
+        <p:spPr>
+          <a:xfrm>
+            <a:off x="9985248" y="6382512"/>
+            <a:ext cx="960120" cy="416755"/>
+          </a:xfrm>
+          <a:prstGeom prst="rect">
+            <a:avLst/>
+          </a:prstGeom>
+        </p:spPr>
+      </p:pic>
     </p:spTree>
   </p:cSld>
   <p:clrMapOvr>
@@ -25755,6 +26319,30 @@
           </a:p>
         </p:txBody>
       </p:sp>
+      <p:pic>
+        <p:nvPicPr>
+          <p:cNvPr id="30" name="Picture 29" descr="softtech-logo.png"/>
+          <p:cNvPicPr>
+            <a:picLocks noChangeAspect="1"/>
+          </p:cNvPicPr>
+          <p:nvPr/>
+        </p:nvPicPr>
+        <p:blipFill>
+          <a:blip r:embed="rId3"/>
+          <a:stretch>
+            <a:fillRect/>
+          </a:stretch>
+        </p:blipFill>
+        <p:spPr>
+          <a:xfrm>
+            <a:off x="9985248" y="6382512"/>
+            <a:ext cx="960120" cy="416755"/>
+          </a:xfrm>
+          <a:prstGeom prst="rect">
+            <a:avLst/>
+          </a:prstGeom>
+        </p:spPr>
+      </p:pic>
     </p:spTree>
   </p:cSld>
   <p:clrMapOvr>
@@ -27123,6 +27711,30 @@
           </a:p>
         </p:txBody>
       </p:sp>
+      <p:pic>
+        <p:nvPicPr>
+          <p:cNvPr id="28" name="Picture 27" descr="softtech-logo.png"/>
+          <p:cNvPicPr>
+            <a:picLocks noChangeAspect="1"/>
+          </p:cNvPicPr>
+          <p:nvPr/>
+        </p:nvPicPr>
+        <p:blipFill>
+          <a:blip r:embed="rId3"/>
+          <a:stretch>
+            <a:fillRect/>
+          </a:stretch>
+        </p:blipFill>
+        <p:spPr>
+          <a:xfrm>
+            <a:off x="9985248" y="6382512"/>
+            <a:ext cx="960120" cy="416755"/>
+          </a:xfrm>
+          <a:prstGeom prst="rect">
+            <a:avLst/>
+          </a:prstGeom>
+        </p:spPr>
+      </p:pic>
     </p:spTree>
   </p:cSld>
   <p:clrMapOvr>
@@ -28475,6 +29087,30 @@
           </a:p>
         </p:txBody>
       </p:sp>
+      <p:pic>
+        <p:nvPicPr>
+          <p:cNvPr id="28" name="Picture 27" descr="softtech-logo.png"/>
+          <p:cNvPicPr>
+            <a:picLocks noChangeAspect="1"/>
+          </p:cNvPicPr>
+          <p:nvPr/>
+        </p:nvPicPr>
+        <p:blipFill>
+          <a:blip r:embed="rId3"/>
+          <a:stretch>
+            <a:fillRect/>
+          </a:stretch>
+        </p:blipFill>
+        <p:spPr>
+          <a:xfrm>
+            <a:off x="9985248" y="6382512"/>
+            <a:ext cx="960120" cy="416755"/>
+          </a:xfrm>
+          <a:prstGeom prst="rect">
+            <a:avLst/>
+          </a:prstGeom>
+        </p:spPr>
+      </p:pic>
     </p:spTree>
   </p:cSld>
   <p:clrMapOvr>
@@ -29859,6 +30495,30 @@
           </a:p>
         </p:txBody>
       </p:sp>
+      <p:pic>
+        <p:nvPicPr>
+          <p:cNvPr id="28" name="Picture 27" descr="softtech-logo.png"/>
+          <p:cNvPicPr>
+            <a:picLocks noChangeAspect="1"/>
+          </p:cNvPicPr>
+          <p:nvPr/>
+        </p:nvPicPr>
+        <p:blipFill>
+          <a:blip r:embed="rId3"/>
+          <a:stretch>
+            <a:fillRect/>
+          </a:stretch>
+        </p:blipFill>
+        <p:spPr>
+          <a:xfrm>
+            <a:off x="9985248" y="6382512"/>
+            <a:ext cx="960120" cy="416755"/>
+          </a:xfrm>
+          <a:prstGeom prst="rect">
+            <a:avLst/>
+          </a:prstGeom>
+        </p:spPr>
+      </p:pic>
     </p:spTree>
   </p:cSld>
   <p:clrMapOvr>

</xml_diff>

<commit_message>
Improve presentation logo contrast
Co-authored-by: Copilot <223556219+Copilot@users.noreply.github.com>
</commit_message>
<xml_diff>
--- a/docs/MevzuAI_Sunum_Guncel.pptx
+++ b/docs/MevzuAI_Sunum_Guncel.pptx
@@ -6053,7 +6053,7 @@
       </p:sp>
       <p:pic>
         <p:nvPicPr>
-          <p:cNvPr id="53" name="Picture 52" descr="softtech-logo.png"/>
+          <p:cNvPr id="53" name="Picture 52" descr="softtech-logo-light-background.png"/>
           <p:cNvPicPr>
             <a:picLocks noChangeAspect="1"/>
           </p:cNvPicPr>
@@ -7336,7 +7336,7 @@
       </p:sp>
       <p:pic>
         <p:nvPicPr>
-          <p:cNvPr id="26" name="Picture 25" descr="softtech-logo.png"/>
+          <p:cNvPr id="26" name="Picture 25" descr="softtech-logo-light-background.png"/>
           <p:cNvPicPr>
             <a:picLocks noChangeAspect="1"/>
           </p:cNvPicPr>
@@ -8420,7 +8420,7 @@
       </p:sp>
       <p:pic>
         <p:nvPicPr>
-          <p:cNvPr id="26" name="Picture 25" descr="softtech-logo.png"/>
+          <p:cNvPr id="26" name="Picture 25" descr="softtech-logo-light-background.png"/>
           <p:cNvPicPr>
             <a:picLocks noChangeAspect="1"/>
           </p:cNvPicPr>
@@ -9719,7 +9719,7 @@
       </p:sp>
       <p:pic>
         <p:nvPicPr>
-          <p:cNvPr id="26" name="Picture 25" descr="softtech-logo.png"/>
+          <p:cNvPr id="26" name="Picture 25" descr="softtech-logo-light-background.png"/>
           <p:cNvPicPr>
             <a:picLocks noChangeAspect="1"/>
           </p:cNvPicPr>
@@ -10716,7 +10716,7 @@
       </p:sp>
       <p:pic>
         <p:nvPicPr>
-          <p:cNvPr id="25" name="Picture 24" descr="softtech-logo.png"/>
+          <p:cNvPr id="25" name="Picture 24" descr="softtech-logo-light-background.png"/>
           <p:cNvPicPr>
             <a:picLocks noChangeAspect="1"/>
           </p:cNvPicPr>
@@ -11284,7 +11284,7 @@
       </p:sp>
       <p:pic>
         <p:nvPicPr>
-          <p:cNvPr id="15" name="Picture 14" descr="softtech-logo.png"/>
+          <p:cNvPr id="15" name="Picture 14" descr="softtech-logo-light-background.png"/>
           <p:cNvPicPr>
             <a:picLocks noChangeAspect="1"/>
           </p:cNvPicPr>
@@ -12483,7 +12483,7 @@
       </p:sp>
       <p:pic>
         <p:nvPicPr>
-          <p:cNvPr id="28" name="Picture 27" descr="softtech-logo.png"/>
+          <p:cNvPr id="28" name="Picture 27" descr="softtech-logo-light-background.png"/>
           <p:cNvPicPr>
             <a:picLocks noChangeAspect="1"/>
           </p:cNvPicPr>
@@ -15453,7 +15453,7 @@
       </p:sp>
       <p:pic>
         <p:nvPicPr>
-          <p:cNvPr id="77" name="Picture 76" descr="softtech-logo.png"/>
+          <p:cNvPr id="77" name="Picture 76" descr="softtech-logo-light-background.png"/>
           <p:cNvPicPr>
             <a:picLocks noChangeAspect="1"/>
           </p:cNvPicPr>
@@ -16236,7 +16236,7 @@
       </p:sp>
       <p:pic>
         <p:nvPicPr>
-          <p:cNvPr id="20" name="Picture 19" descr="softtech-logo.png"/>
+          <p:cNvPr id="20" name="Picture 19" descr="softtech-logo-light-background.png"/>
           <p:cNvPicPr>
             <a:picLocks noChangeAspect="1"/>
           </p:cNvPicPr>
@@ -16667,7 +16667,7 @@
       </p:sp>
       <p:pic>
         <p:nvPicPr>
-          <p:cNvPr id="10" name="Picture 9" descr="softtech-logo.png"/>
+          <p:cNvPr id="10" name="Picture 9" descr="softtech-logo-light-background.png"/>
           <p:cNvPicPr>
             <a:picLocks noChangeAspect="1"/>
           </p:cNvPicPr>
@@ -17410,7 +17410,7 @@
       </p:sp>
       <p:pic>
         <p:nvPicPr>
-          <p:cNvPr id="16" name="Picture 15" descr="softtech-logo.png"/>
+          <p:cNvPr id="16" name="Picture 15" descr="softtech-logo-light-background.png"/>
           <p:cNvPicPr>
             <a:picLocks noChangeAspect="1"/>
           </p:cNvPicPr>
@@ -18413,7 +18413,7 @@
       </p:sp>
       <p:pic>
         <p:nvPicPr>
-          <p:cNvPr id="26" name="Picture 25" descr="softtech-logo.png"/>
+          <p:cNvPr id="26" name="Picture 25" descr="softtech-logo-light-background.png"/>
           <p:cNvPicPr>
             <a:picLocks noChangeAspect="1"/>
           </p:cNvPicPr>
@@ -19078,7 +19078,7 @@
       </p:sp>
       <p:pic>
         <p:nvPicPr>
-          <p:cNvPr id="7" name="Picture 6" descr="softtech-logo.png"/>
+          <p:cNvPr id="7" name="Picture 6" descr="softtech-logo-light-background.png"/>
           <p:cNvPicPr>
             <a:picLocks noChangeAspect="1"/>
           </p:cNvPicPr>
@@ -19864,7 +19864,7 @@
       </p:sp>
       <p:pic>
         <p:nvPicPr>
-          <p:cNvPr id="20" name="Picture 19" descr="softtech-logo.png"/>
+          <p:cNvPr id="20" name="Picture 19" descr="softtech-logo-light-background.png"/>
           <p:cNvPicPr>
             <a:picLocks noChangeAspect="1"/>
           </p:cNvPicPr>
@@ -20082,7 +20082,7 @@
       </p:sp>
       <p:pic>
         <p:nvPicPr>
-          <p:cNvPr id="7" name="Picture 6" descr="softtech-logo.png"/>
+          <p:cNvPr id="7" name="Picture 6" descr="softtech-logo-light-background.png"/>
           <p:cNvPicPr>
             <a:picLocks noChangeAspect="1"/>
           </p:cNvPicPr>
@@ -20300,7 +20300,7 @@
       </p:sp>
       <p:pic>
         <p:nvPicPr>
-          <p:cNvPr id="7" name="Picture 6" descr="softtech-logo.png"/>
+          <p:cNvPr id="7" name="Picture 6" descr="softtech-logo-light-background.png"/>
           <p:cNvPicPr>
             <a:picLocks noChangeAspect="1"/>
           </p:cNvPicPr>
@@ -20518,7 +20518,7 @@
       </p:sp>
       <p:pic>
         <p:nvPicPr>
-          <p:cNvPr id="7" name="Picture 6" descr="softtech-logo.png"/>
+          <p:cNvPr id="7" name="Picture 6" descr="softtech-logo-light-background.png"/>
           <p:cNvPicPr>
             <a:picLocks noChangeAspect="1"/>
           </p:cNvPicPr>
@@ -20736,7 +20736,7 @@
       </p:sp>
       <p:pic>
         <p:nvPicPr>
-          <p:cNvPr id="7" name="Picture 6" descr="softtech-logo.png"/>
+          <p:cNvPr id="7" name="Picture 6" descr="softtech-logo-light-background.png"/>
           <p:cNvPicPr>
             <a:picLocks noChangeAspect="1"/>
           </p:cNvPicPr>
@@ -23116,7 +23116,7 @@
       </p:sp>
       <p:pic>
         <p:nvPicPr>
-          <p:cNvPr id="57" name="Picture 56" descr="softtech-logo.png"/>
+          <p:cNvPr id="57" name="Picture 56" descr="softtech-logo-light-background.png"/>
           <p:cNvPicPr>
             <a:picLocks noChangeAspect="1"/>
           </p:cNvPicPr>
@@ -23992,7 +23992,7 @@
       </p:sp>
       <p:pic>
         <p:nvPicPr>
-          <p:cNvPr id="18" name="Picture 17" descr="softtech-logo.png"/>
+          <p:cNvPr id="18" name="Picture 17" descr="softtech-logo-light-background.png"/>
           <p:cNvPicPr>
             <a:picLocks noChangeAspect="1"/>
           </p:cNvPicPr>
@@ -24820,7 +24820,7 @@
       </p:sp>
       <p:pic>
         <p:nvPicPr>
-          <p:cNvPr id="18" name="Picture 17" descr="softtech-logo.png"/>
+          <p:cNvPr id="18" name="Picture 17" descr="softtech-logo-light-background.png"/>
           <p:cNvPicPr>
             <a:picLocks noChangeAspect="1"/>
           </p:cNvPicPr>
@@ -26321,7 +26321,7 @@
       </p:sp>
       <p:pic>
         <p:nvPicPr>
-          <p:cNvPr id="30" name="Picture 29" descr="softtech-logo.png"/>
+          <p:cNvPr id="30" name="Picture 29" descr="softtech-logo-light-background.png"/>
           <p:cNvPicPr>
             <a:picLocks noChangeAspect="1"/>
           </p:cNvPicPr>
@@ -27713,7 +27713,7 @@
       </p:sp>
       <p:pic>
         <p:nvPicPr>
-          <p:cNvPr id="28" name="Picture 27" descr="softtech-logo.png"/>
+          <p:cNvPr id="28" name="Picture 27" descr="softtech-logo-light-background.png"/>
           <p:cNvPicPr>
             <a:picLocks noChangeAspect="1"/>
           </p:cNvPicPr>
@@ -29089,7 +29089,7 @@
       </p:sp>
       <p:pic>
         <p:nvPicPr>
-          <p:cNvPr id="28" name="Picture 27" descr="softtech-logo.png"/>
+          <p:cNvPr id="28" name="Picture 27" descr="softtech-logo-light-background.png"/>
           <p:cNvPicPr>
             <a:picLocks noChangeAspect="1"/>
           </p:cNvPicPr>
@@ -30497,7 +30497,7 @@
       </p:sp>
       <p:pic>
         <p:nvPicPr>
-          <p:cNvPr id="28" name="Picture 27" descr="softtech-logo.png"/>
+          <p:cNvPr id="28" name="Picture 27" descr="softtech-logo-light-background.png"/>
           <p:cNvPicPr>
             <a:picLocks noChangeAspect="1"/>
           </p:cNvPicPr>

</xml_diff>